<commit_message>
Correct submitter identity in English deck (Mahmoud Samaha / mhmud.smaha@gmail.com)
</commit_message>
<xml_diff>
--- a/SAKINA_Pitch_Deck.pptx
+++ b/SAKINA_Pitch_Deck.pptx
@@ -1887,7 +1887,7 @@
                 <a:ea typeface="Calibri" pitchFamily="34" charset="-122"/>
                 <a:cs typeface="Calibri" pitchFamily="34" charset="-120"/>
               </a:rPr>
-              <a:t>Team SAKINA  ·  MhmoodHmmam  ·  Idea Phase submission, 20 Aug 2026</a:t>
+              <a:t>Team SAKINA  ·  Mahmoud Samaha  ·  Idea Phase submission, 20 Aug 2026</a:t>
             </a:r>
             <a:endParaRPr lang="en-US" sz="1100" dirty="0"/>
           </a:p>
@@ -3947,7 +3947,7 @@
                 <a:ea typeface="Calibri" pitchFamily="34" charset="-122"/>
                 <a:cs typeface="Calibri" pitchFamily="34" charset="-120"/>
               </a:rPr>
-              <a:t>MhmoodHmmam — solo builder: agent design, CAMARA integration, full stack</a:t>
+              <a:t>Mahmoud Samaha — solo builder: agent design, CAMARA integration, full stack</a:t>
             </a:r>
             <a:endParaRPr lang="en-US" sz="1300" dirty="0"/>
           </a:p>
@@ -3986,7 +3986,7 @@
                 <a:ea typeface="Courier New" pitchFamily="34" charset="-122"/>
                 <a:cs typeface="Courier New" pitchFamily="34" charset="-120"/>
               </a:rPr>
-              <a:t>mhmood.hmmam@gmail.com</a:t>
+              <a:t>mhmud.smaha@gmail.com</a:t>
             </a:r>
             <a:endParaRPr lang="en-US" sz="1200" dirty="0"/>
           </a:p>

</xml_diff>

<commit_message>
Pitch decks (EN/AR): Prototype-phase facts, 7 APIs, 53 tests, live URLs, new 'What's different' slide
Co-Authored-By: Claude Opus 5 <noreply@anthropic.com>
</commit_message>
<xml_diff>
--- a/SAKINA_Pitch_Deck.pptx
+++ b/SAKINA_Pitch_Deck.pptx
@@ -19,6 +19,7 @@
     <p:sldId id="264" r:id="rId10"/>
     <p:sldId id="265" r:id="rId11"/>
     <p:sldId id="266" r:id="rId12"/>
+    <p:sldId id="268" r:id="rId19"/>
     <p:sldId id="267" r:id="rId13"/>
   </p:sldIdLst>
   <p:sldSz cx="12192000" cy="6858000"/>
@@ -1887,7 +1888,7 @@
                 <a:ea typeface="Calibri" pitchFamily="34" charset="-122"/>
                 <a:cs typeface="Calibri" pitchFamily="34" charset="-120"/>
               </a:rPr>
-              <a:t>Team SAKINA  ·  Mahmoud Samaha  ·  Idea Phase submission, 20 Aug 2026</a:t>
+              <a:t>Team SAKINA  ·  Mahmoud Samaha  ·  Prototype Phase submission, September 2026</a:t>
             </a:r>
             <a:endParaRPr lang="en-US" sz="1100" dirty="0"/>
           </a:p>
@@ -3485,7 +3486,7 @@
                 <a:ea typeface="Calibri" pitchFamily="34" charset="-122"/>
                 <a:cs typeface="Calibri" pitchFamily="34" charset="-120"/>
               </a:rPr>
-              <a:t>5 CAMARA API families live-verified in one LangGraph state machine; conditional edges chosen by the agent, not the operator</a:t>
+              <a:t>7 CAMARA APIs, six orchestrated in one LangGraph state machine; the conditional edges are chosen by the agent, not the operator</a:t>
             </a:r>
             <a:endParaRPr lang="en-US" sz="1200" dirty="0"/>
           </a:p>
@@ -3589,7 +3590,7 @@
                 <a:ea typeface="Calibri" pitchFamily="34" charset="-122"/>
                 <a:cs typeface="Calibri" pitchFamily="34" charset="-120"/>
               </a:rPr>
-              <a:t>Live Nokia NaC calls, live QoD session created and released, 21 passing tests, replay mode needs zero credentials</a:t>
+              <a:t>Deployed on Streamlit Cloud, live Nokia NaC calls, live QoD session created and released, 53 passing tests with CI, replay mode needs zero credentials</a:t>
             </a:r>
             <a:endParaRPr lang="en-US" sz="1200" dirty="0"/>
           </a:p>
@@ -4025,7 +4026,7 @@
                 <a:ea typeface="Calibri" pitchFamily="34" charset="-122"/>
                 <a:cs typeface="Calibri" pitchFamily="34" charset="-120"/>
               </a:rPr>
-              <a:t>NEXT</a:t>
+              <a:t>LIVE</a:t>
             </a:r>
             <a:endParaRPr lang="en-US" sz="1100" dirty="0"/>
           </a:p>
@@ -4064,7 +4065,7 @@
                 <a:ea typeface="Calibri" pitchFamily="34" charset="-122"/>
                 <a:cs typeface="Calibri" pitchFamily="34" charset="-120"/>
               </a:rPr>
-              <a:t>Prototype hardening through Sep 8 · live demo + submission by Sep 12</a:t>
+              <a:t>sakina.streamlit.app · github.com/MhmoodHmmam/sakina · narrated demo video with the submission</a:t>
             </a:r>
             <a:endParaRPr lang="en-US" sz="1400" dirty="0"/>
           </a:p>
@@ -4106,6 +4107,1044 @@
               <a:t>GSMA MENA IGNITE HACKATHON · THEME 3 — TOURISM, PILGRIMAGE &amp; CULTURAL EXPERIENCE INNOVATION</a:t>
             </a:r>
             <a:endParaRPr lang="en-US" sz="1050" dirty="0"/>
+          </a:p>
+        </p:txBody>
+      </p:sp>
+    </p:spTree>
+  </p:cSld>
+  <p:clrMapOvr>
+    <a:masterClrMapping/>
+  </p:clrMapOvr>
+</p:sld>
+</file>
+
+<file path=ppt/slides/slide13.xml><?xml version="1.0" encoding="utf-8"?>
+<p:sld xmlns:a="http://schemas.openxmlformats.org/drawingml/2006/main" xmlns:r="http://schemas.openxmlformats.org/officeDocument/2006/relationships" xmlns:p="http://schemas.openxmlformats.org/presentationml/2006/main">
+  <p:cSld name="Slide 10">
+    <p:bg>
+      <p:bgPr>
+        <a:solidFill>
+          <a:srgbClr val="FFFFFF"/>
+        </a:solidFill>
+        <a:effectLst/>
+      </p:bgPr>
+    </p:bg>
+    <p:spTree>
+      <p:nvGrpSpPr>
+        <p:cNvPr id="1" name=""/>
+        <p:cNvGrpSpPr/>
+        <p:nvPr/>
+      </p:nvGrpSpPr>
+      <p:grpSpPr>
+        <a:xfrm>
+          <a:off x="0" y="0"/>
+          <a:ext cx="0" cy="0"/>
+          <a:chOff x="0" y="0"/>
+          <a:chExt cx="0" cy="0"/>
+        </a:xfrm>
+      </p:grpSpPr>
+      <p:sp>
+        <p:nvSpPr>
+          <p:cNvPr id="2" name="Text 0"/>
+          <p:cNvSpPr/>
+          <p:nvPr/>
+        </p:nvSpPr>
+        <p:spPr>
+          <a:xfrm>
+            <a:off x="548640" y="365760"/>
+            <a:ext cx="7315200" cy="320040"/>
+          </a:xfrm>
+          <a:prstGeom prst="rect">
+            <a:avLst/>
+          </a:prstGeom>
+          <a:noFill/>
+          <a:ln/>
+        </p:spPr>
+        <p:txBody>
+          <a:bodyPr wrap="square" lIns="0" tIns="0" rIns="0" bIns="0" rtlCol="0" anchor="ctr"/>
+          <a:lstStyle/>
+          <a:p>
+            <a:pPr marL="0" indent="0">
+              <a:buNone/>
+            </a:pPr>
+            <a:r>
+              <a:rPr lang="en-US" sz="1100" b="1" kern="0" spc="200" dirty="0">
+                <a:solidFill>
+                  <a:srgbClr val="0F6E56"/>
+                </a:solidFill>
+                <a:latin typeface="Calibri" pitchFamily="34" charset="0"/>
+                <a:ea typeface="Calibri" pitchFamily="34" charset="-122"/>
+                <a:cs typeface="Calibri" pitchFamily="34" charset="-120"/>
+              </a:rPr>
+              <a:t>WHAT'S DIFFERENT</a:t>
+            </a:r>
+            <a:endParaRPr lang="en-US" sz="1100" dirty="0"/>
+          </a:p>
+        </p:txBody>
+      </p:sp>
+      <p:sp>
+        <p:nvSpPr>
+          <p:cNvPr id="3" name="Text 1"/>
+          <p:cNvSpPr/>
+          <p:nvPr/>
+        </p:nvSpPr>
+        <p:spPr>
+          <a:xfrm>
+            <a:off x="548640" y="640080"/>
+            <a:ext cx="11064240" cy="594360"/>
+          </a:xfrm>
+          <a:prstGeom prst="rect">
+            <a:avLst/>
+          </a:prstGeom>
+          <a:noFill/>
+          <a:ln/>
+        </p:spPr>
+        <p:txBody>
+          <a:bodyPr wrap="square" lIns="0" tIns="0" rIns="0" bIns="0" rtlCol="0" anchor="ctr"/>
+          <a:lstStyle/>
+          <a:p>
+            <a:pPr marL="0" indent="0">
+              <a:buNone/>
+            </a:pPr>
+            <a:r>
+              <a:rPr lang="en-US" sz="2300" b="1" dirty="0">
+                <a:solidFill>
+                  <a:srgbClr val="16202B"/>
+                </a:solidFill>
+                <a:latin typeface="Cambria" pitchFamily="34" charset="0"/>
+                <a:ea typeface="Cambria" pitchFamily="34" charset="-122"/>
+                <a:cs typeface="Cambria" pitchFamily="34" charset="-120"/>
+              </a:rPr>
+              <a:t>Built on known ground — one step further</a:t>
+            </a:r>
+            <a:endParaRPr lang="en-US" sz="2300" dirty="0"/>
+          </a:p>
+        </p:txBody>
+      </p:sp>
+      <p:graphicFrame>
+        <p:nvGraphicFramePr>
+          <p:cNvPr id="11" name="Table 0"/>
+          <p:cNvGraphicFramePr>
+            <a:graphicFrameLocks noGrp="1"/>
+          </p:cNvGraphicFramePr>
+          <p:nvPr>
+            <p:extLst>
+              <p:ext uri="{D42A27DB-BD31-4B8C-83A1-F6EECF244321}">
+                <p14:modId xmlns:p14="http://schemas.microsoft.com/office/powerpoint/2010/main" val="1579011935"/>
+              </p:ext>
+            </p:extLst>
+          </p:nvPr>
+        </p:nvGraphicFramePr>
+        <p:xfrm>
+          <a:off x="548640" y="1417320"/>
+          <a:ext cx="7315200" cy="4709160"/>
+        </p:xfrm>
+        <a:graphic>
+          <a:graphicData uri="http://schemas.openxmlformats.org/drawingml/2006/table">
+            <a:tbl>
+              <a:tblPr/>
+              <a:tblGrid>
+                <a:gridCol w="3072384">
+                  <a:extLst>
+                    <a:ext uri="{9D8B030D-6E8A-4147-A177-3AD203B41FA5}">
+                      <a16:colId xmlns:a16="http://schemas.microsoft.com/office/drawing/2014/main" val="20000"/>
+                    </a:ext>
+                  </a:extLst>
+                </a:gridCol>
+                <a:gridCol w="4242816">
+                  <a:extLst>
+                    <a:ext uri="{9D8B030D-6E8A-4147-A177-3AD203B41FA5}">
+                      <a16:colId xmlns:a16="http://schemas.microsoft.com/office/drawing/2014/main" val="20001"/>
+                    </a:ext>
+                  </a:extLst>
+                </a:gridCol>
+              </a:tblGrid>
+              <a:tr h="941832">
+                <a:tc>
+                  <a:txBody>
+                    <a:bodyPr/>
+                    <a:lstStyle/>
+                    <a:p>
+                      <a:pPr marL="0" indent="0">
+                        <a:buNone/>
+                      </a:pPr>
+                      <a:r>
+                        <a:rPr lang="en-US" sz="1200" b="1" dirty="0">
+                          <a:solidFill>
+                            <a:srgbClr val="FFFFFF"/>
+                          </a:solidFill>
+                          <a:latin typeface="Calibri" pitchFamily="34" charset="0"/>
+                          <a:ea typeface="Calibri" pitchFamily="34" charset="-122"/>
+                          <a:cs typeface="Calibri" pitchFamily="34" charset="-120"/>
+                        </a:rPr>
+                        <a:t>Exists today</a:t>
+                      </a:r>
+                      <a:endParaRPr lang="en-US" sz="1200" dirty="0">
+                        <a:latin typeface="Calibri" charset="0"/>
+                        <a:ea typeface="Calibri" charset="0"/>
+                        <a:cs typeface="Calibri" charset="0"/>
+                      </a:endParaRPr>
+                    </a:p>
+                  </a:txBody>
+                  <a:tcPr anchor="ctr">
+                    <a:lnL w="6350" cap="flat" cmpd="sng" algn="ctr">
+                      <a:solidFill>
+                        <a:srgbClr val="D8DEE4"/>
+                      </a:solidFill>
+                      <a:prstDash val="solid"/>
+                      <a:round/>
+                      <a:headEnd type="none" w="med" len="med"/>
+                      <a:tailEnd type="none" w="med" len="med"/>
+                    </a:lnL>
+                    <a:lnR w="6350" cap="flat" cmpd="sng" algn="ctr">
+                      <a:solidFill>
+                        <a:srgbClr val="D8DEE4"/>
+                      </a:solidFill>
+                      <a:prstDash val="solid"/>
+                      <a:round/>
+                      <a:headEnd type="none" w="med" len="med"/>
+                      <a:tailEnd type="none" w="med" len="med"/>
+                    </a:lnR>
+                    <a:lnT w="6350" cap="flat" cmpd="sng" algn="ctr">
+                      <a:solidFill>
+                        <a:srgbClr val="D8DEE4"/>
+                      </a:solidFill>
+                      <a:prstDash val="solid"/>
+                      <a:round/>
+                      <a:headEnd type="none" w="med" len="med"/>
+                      <a:tailEnd type="none" w="med" len="med"/>
+                    </a:lnT>
+                    <a:lnB w="6350" cap="flat" cmpd="sng" algn="ctr">
+                      <a:solidFill>
+                        <a:srgbClr val="D8DEE4"/>
+                      </a:solidFill>
+                      <a:prstDash val="solid"/>
+                      <a:round/>
+                      <a:headEnd type="none" w="med" len="med"/>
+                      <a:tailEnd type="none" w="med" len="med"/>
+                    </a:lnB>
+                    <a:solidFill>
+                      <a:srgbClr val="0F1B2D"/>
+                    </a:solidFill>
+                  </a:tcPr>
+                </a:tc>
+                <a:tc>
+                  <a:txBody>
+                    <a:bodyPr/>
+                    <a:lstStyle/>
+                    <a:p>
+                      <a:pPr marL="0" indent="0">
+                        <a:buNone/>
+                      </a:pPr>
+                      <a:r>
+                        <a:rPr lang="en-US" sz="1200" b="1" dirty="0">
+                          <a:solidFill>
+                            <a:srgbClr val="FFFFFF"/>
+                          </a:solidFill>
+                          <a:latin typeface="Calibri" pitchFamily="34" charset="0"/>
+                          <a:ea typeface="Calibri" pitchFamily="34" charset="-122"/>
+                          <a:cs typeface="Calibri" pitchFamily="34" charset="-120"/>
+                        </a:rPr>
+                        <a:t>SAKINA adds</a:t>
+                      </a:r>
+                      <a:endParaRPr lang="en-US" sz="1200" dirty="0">
+                        <a:latin typeface="Calibri" charset="0"/>
+                        <a:ea typeface="Calibri" charset="0"/>
+                        <a:cs typeface="Calibri" charset="0"/>
+                      </a:endParaRPr>
+                    </a:p>
+                  </a:txBody>
+                  <a:tcPr anchor="ctr">
+                    <a:lnL w="6350" cap="flat" cmpd="sng" algn="ctr">
+                      <a:solidFill>
+                        <a:srgbClr val="D8DEE4"/>
+                      </a:solidFill>
+                      <a:prstDash val="solid"/>
+                      <a:round/>
+                      <a:headEnd type="none" w="med" len="med"/>
+                      <a:tailEnd type="none" w="med" len="med"/>
+                    </a:lnL>
+                    <a:lnR w="6350" cap="flat" cmpd="sng" algn="ctr">
+                      <a:solidFill>
+                        <a:srgbClr val="D8DEE4"/>
+                      </a:solidFill>
+                      <a:prstDash val="solid"/>
+                      <a:round/>
+                      <a:headEnd type="none" w="med" len="med"/>
+                      <a:tailEnd type="none" w="med" len="med"/>
+                    </a:lnR>
+                    <a:lnT w="6350" cap="flat" cmpd="sng" algn="ctr">
+                      <a:solidFill>
+                        <a:srgbClr val="D8DEE4"/>
+                      </a:solidFill>
+                      <a:prstDash val="solid"/>
+                      <a:round/>
+                      <a:headEnd type="none" w="med" len="med"/>
+                      <a:tailEnd type="none" w="med" len="med"/>
+                    </a:lnT>
+                    <a:lnB w="6350" cap="flat" cmpd="sng" algn="ctr">
+                      <a:solidFill>
+                        <a:srgbClr val="D8DEE4"/>
+                      </a:solidFill>
+                      <a:prstDash val="solid"/>
+                      <a:round/>
+                      <a:headEnd type="none" w="med" len="med"/>
+                      <a:tailEnd type="none" w="med" len="med"/>
+                    </a:lnB>
+                    <a:solidFill>
+                      <a:srgbClr val="0F1B2D"/>
+                    </a:solidFill>
+                  </a:tcPr>
+                </a:tc>
+                <a:extLst>
+                  <a:ext uri="{0D108BD9-81ED-4DB2-BD59-A6C34878D82A}">
+                    <a16:rowId xmlns:a16="http://schemas.microsoft.com/office/drawing/2014/main" val="10000"/>
+                  </a:ext>
+                </a:extLst>
+              </a:tr>
+              <a:tr h="941832">
+                <a:tc>
+                  <a:txBody>
+                    <a:bodyPr/>
+                    <a:lstStyle/>
+                    <a:p>
+                      <a:pPr marL="0" indent="0">
+                        <a:buNone/>
+                      </a:pPr>
+                      <a:r>
+                        <a:rPr lang="en-US" sz="1200" dirty="0">
+                          <a:solidFill>
+                            <a:srgbClr val="16202B"/>
+                          </a:solidFill>
+                          <a:latin typeface="Calibri" pitchFamily="34" charset="0"/>
+                          <a:ea typeface="Calibri" pitchFamily="34" charset="-122"/>
+                          <a:cs typeface="Calibri" pitchFamily="34" charset="-120"/>
+                        </a:rPr>
+                        <a:t>The network as a crowd sensor — signalling-data research (PLOS ONE 2024); population-density APIs at Paris 2024</a:t>
+                      </a:r>
+                      <a:endParaRPr lang="en-US" sz="1200" dirty="0">
+                        <a:latin typeface="Calibri" charset="0"/>
+                        <a:ea typeface="Calibri" charset="0"/>
+                        <a:cs typeface="Calibri" charset="0"/>
+                      </a:endParaRPr>
+                    </a:p>
+                  </a:txBody>
+                  <a:tcPr anchor="ctr">
+                    <a:lnL w="6350" cap="flat" cmpd="sng" algn="ctr">
+                      <a:solidFill>
+                        <a:srgbClr val="D8DEE4"/>
+                      </a:solidFill>
+                      <a:prstDash val="solid"/>
+                      <a:round/>
+                      <a:headEnd type="none" w="med" len="med"/>
+                      <a:tailEnd type="none" w="med" len="med"/>
+                    </a:lnL>
+                    <a:lnR w="6350" cap="flat" cmpd="sng" algn="ctr">
+                      <a:solidFill>
+                        <a:srgbClr val="D8DEE4"/>
+                      </a:solidFill>
+                      <a:prstDash val="solid"/>
+                      <a:round/>
+                      <a:headEnd type="none" w="med" len="med"/>
+                      <a:tailEnd type="none" w="med" len="med"/>
+                    </a:lnR>
+                    <a:lnT w="6350" cap="flat" cmpd="sng" algn="ctr">
+                      <a:solidFill>
+                        <a:srgbClr val="D8DEE4"/>
+                      </a:solidFill>
+                      <a:prstDash val="solid"/>
+                      <a:round/>
+                      <a:headEnd type="none" w="med" len="med"/>
+                      <a:tailEnd type="none" w="med" len="med"/>
+                    </a:lnT>
+                    <a:lnB w="6350" cap="flat" cmpd="sng" algn="ctr">
+                      <a:solidFill>
+                        <a:srgbClr val="D8DEE4"/>
+                      </a:solidFill>
+                      <a:prstDash val="solid"/>
+                      <a:round/>
+                      <a:headEnd type="none" w="med" len="med"/>
+                      <a:tailEnd type="none" w="med" len="med"/>
+                    </a:lnB>
+                  </a:tcPr>
+                </a:tc>
+                <a:tc>
+                  <a:txBody>
+                    <a:bodyPr/>
+                    <a:lstStyle/>
+                    <a:p>
+                      <a:pPr marL="0" indent="0">
+                        <a:buNone/>
+                      </a:pPr>
+                      <a:r>
+                        <a:rPr lang="en-US" sz="1200" dirty="0">
+                          <a:solidFill>
+                            <a:srgbClr val="16202B"/>
+                          </a:solidFill>
+                          <a:latin typeface="Calibri" pitchFamily="34" charset="0"/>
+                          <a:ea typeface="Calibri" pitchFamily="34" charset="-122"/>
+                          <a:cs typeface="Calibri" pitchFamily="34" charset="-120"/>
+                        </a:rPr>
+                        <a:t>Closes the loop: sense, judge, act — no operator trigger and no new hardware; every pilgrim already carries the sensor.</a:t>
+                      </a:r>
+                      <a:endParaRPr lang="en-US" sz="1200" dirty="0">
+                        <a:latin typeface="Calibri" charset="0"/>
+                        <a:ea typeface="Calibri" charset="0"/>
+                        <a:cs typeface="Calibri" charset="0"/>
+                      </a:endParaRPr>
+                    </a:p>
+                  </a:txBody>
+                  <a:tcPr anchor="ctr">
+                    <a:lnL w="6350" cap="flat" cmpd="sng" algn="ctr">
+                      <a:solidFill>
+                        <a:srgbClr val="D8DEE4"/>
+                      </a:solidFill>
+                      <a:prstDash val="solid"/>
+                      <a:round/>
+                      <a:headEnd type="none" w="med" len="med"/>
+                      <a:tailEnd type="none" w="med" len="med"/>
+                    </a:lnL>
+                    <a:lnR w="6350" cap="flat" cmpd="sng" algn="ctr">
+                      <a:solidFill>
+                        <a:srgbClr val="D8DEE4"/>
+                      </a:solidFill>
+                      <a:prstDash val="solid"/>
+                      <a:round/>
+                      <a:headEnd type="none" w="med" len="med"/>
+                      <a:tailEnd type="none" w="med" len="med"/>
+                    </a:lnR>
+                    <a:lnT w="6350" cap="flat" cmpd="sng" algn="ctr">
+                      <a:solidFill>
+                        <a:srgbClr val="D8DEE4"/>
+                      </a:solidFill>
+                      <a:prstDash val="solid"/>
+                      <a:round/>
+                      <a:headEnd type="none" w="med" len="med"/>
+                      <a:tailEnd type="none" w="med" len="med"/>
+                    </a:lnT>
+                    <a:lnB w="6350" cap="flat" cmpd="sng" algn="ctr">
+                      <a:solidFill>
+                        <a:srgbClr val="D8DEE4"/>
+                      </a:solidFill>
+                      <a:prstDash val="solid"/>
+                      <a:round/>
+                      <a:headEnd type="none" w="med" len="med"/>
+                      <a:tailEnd type="none" w="med" len="med"/>
+                    </a:lnB>
+                  </a:tcPr>
+                </a:tc>
+                <a:extLst>
+                  <a:ext uri="{0D108BD9-81ED-4DB2-BD59-A6C34878D82A}">
+                    <a16:rowId xmlns:a16="http://schemas.microsoft.com/office/drawing/2014/main" val="10001"/>
+                  </a:ext>
+                </a:extLst>
+              </a:tr>
+              <a:tr h="941832">
+                <a:tc>
+                  <a:txBody>
+                    <a:bodyPr/>
+                    <a:lstStyle/>
+                    <a:p>
+                      <a:pPr marL="0" indent="0">
+                        <a:buNone/>
+                      </a:pPr>
+                      <a:r>
+                        <a:rPr lang="en-US" sz="1200" dirty="0">
+                          <a:solidFill>
+                            <a:srgbClr val="16202B"/>
+                          </a:solidFill>
+                          <a:latin typeface="Calibri" pitchFamily="34" charset="0"/>
+                          <a:ea typeface="Calibri" pitchFamily="34" charset="-122"/>
+                          <a:cs typeface="Calibri" pitchFamily="34" charset="-120"/>
+                        </a:rPr>
+                        <a:t>Agents that raise QoD when congestion rises — Nokia × Summit Tech at MWC26, for an 8K stream</a:t>
+                      </a:r>
+                      <a:endParaRPr lang="en-US" sz="1200" dirty="0">
+                        <a:latin typeface="Calibri" charset="0"/>
+                        <a:ea typeface="Calibri" charset="0"/>
+                        <a:cs typeface="Calibri" charset="0"/>
+                      </a:endParaRPr>
+                    </a:p>
+                  </a:txBody>
+                  <a:tcPr anchor="ctr">
+                    <a:lnL w="6350" cap="flat" cmpd="sng" algn="ctr">
+                      <a:solidFill>
+                        <a:srgbClr val="D8DEE4"/>
+                      </a:solidFill>
+                      <a:prstDash val="solid"/>
+                      <a:round/>
+                      <a:headEnd type="none" w="med" len="med"/>
+                      <a:tailEnd type="none" w="med" len="med"/>
+                    </a:lnL>
+                    <a:lnR w="6350" cap="flat" cmpd="sng" algn="ctr">
+                      <a:solidFill>
+                        <a:srgbClr val="D8DEE4"/>
+                      </a:solidFill>
+                      <a:prstDash val="solid"/>
+                      <a:round/>
+                      <a:headEnd type="none" w="med" len="med"/>
+                      <a:tailEnd type="none" w="med" len="med"/>
+                    </a:lnR>
+                    <a:lnT w="6350" cap="flat" cmpd="sng" algn="ctr">
+                      <a:solidFill>
+                        <a:srgbClr val="D8DEE4"/>
+                      </a:solidFill>
+                      <a:prstDash val="solid"/>
+                      <a:round/>
+                      <a:headEnd type="none" w="med" len="med"/>
+                      <a:tailEnd type="none" w="med" len="med"/>
+                    </a:lnT>
+                    <a:lnB w="6350" cap="flat" cmpd="sng" algn="ctr">
+                      <a:solidFill>
+                        <a:srgbClr val="D8DEE4"/>
+                      </a:solidFill>
+                      <a:prstDash val="solid"/>
+                      <a:round/>
+                      <a:headEnd type="none" w="med" len="med"/>
+                      <a:tailEnd type="none" w="med" len="med"/>
+                    </a:lnB>
+                  </a:tcPr>
+                </a:tc>
+                <a:tc>
+                  <a:txBody>
+                    <a:bodyPr/>
+                    <a:lstStyle/>
+                    <a:p>
+                      <a:pPr marL="0" indent="0">
+                        <a:buNone/>
+                      </a:pPr>
+                      <a:r>
+                        <a:rPr lang="en-US" sz="1200" dirty="0">
+                          <a:solidFill>
+                            <a:srgbClr val="16202B"/>
+                          </a:solidFill>
+                          <a:latin typeface="Calibri" pitchFamily="34" charset="0"/>
+                          <a:ea typeface="Calibri" pitchFamily="34" charset="-122"/>
+                          <a:cs typeface="Calibri" pitchFamily="34" charset="-120"/>
+                        </a:rPr>
+                        <a:t>Weighs the evidence: every reading carries its confidence; the agent asks whether a falling reading is dispersal or blindness, and decides when that doubt is worth more API calls.</a:t>
+                      </a:r>
+                      <a:endParaRPr lang="en-US" sz="1200" dirty="0">
+                        <a:latin typeface="Calibri" charset="0"/>
+                        <a:ea typeface="Calibri" charset="0"/>
+                        <a:cs typeface="Calibri" charset="0"/>
+                      </a:endParaRPr>
+                    </a:p>
+                  </a:txBody>
+                  <a:tcPr anchor="ctr">
+                    <a:lnL w="6350" cap="flat" cmpd="sng" algn="ctr">
+                      <a:solidFill>
+                        <a:srgbClr val="D8DEE4"/>
+                      </a:solidFill>
+                      <a:prstDash val="solid"/>
+                      <a:round/>
+                      <a:headEnd type="none" w="med" len="med"/>
+                      <a:tailEnd type="none" w="med" len="med"/>
+                    </a:lnL>
+                    <a:lnR w="6350" cap="flat" cmpd="sng" algn="ctr">
+                      <a:solidFill>
+                        <a:srgbClr val="D8DEE4"/>
+                      </a:solidFill>
+                      <a:prstDash val="solid"/>
+                      <a:round/>
+                      <a:headEnd type="none" w="med" len="med"/>
+                      <a:tailEnd type="none" w="med" len="med"/>
+                    </a:lnR>
+                    <a:lnT w="6350" cap="flat" cmpd="sng" algn="ctr">
+                      <a:solidFill>
+                        <a:srgbClr val="D8DEE4"/>
+                      </a:solidFill>
+                      <a:prstDash val="solid"/>
+                      <a:round/>
+                      <a:headEnd type="none" w="med" len="med"/>
+                      <a:tailEnd type="none" w="med" len="med"/>
+                    </a:lnT>
+                    <a:lnB w="6350" cap="flat" cmpd="sng" algn="ctr">
+                      <a:solidFill>
+                        <a:srgbClr val="D8DEE4"/>
+                      </a:solidFill>
+                      <a:prstDash val="solid"/>
+                      <a:round/>
+                      <a:headEnd type="none" w="med" len="med"/>
+                      <a:tailEnd type="none" w="med" len="med"/>
+                    </a:lnB>
+                  </a:tcPr>
+                </a:tc>
+                <a:extLst>
+                  <a:ext uri="{0D108BD9-81ED-4DB2-BD59-A6C34878D82A}">
+                    <a16:rowId xmlns:a16="http://schemas.microsoft.com/office/drawing/2014/main" val="10002"/>
+                  </a:ext>
+                </a:extLst>
+              </a:tr>
+              <a:tr h="941832">
+                <a:tc>
+                  <a:txBody>
+                    <a:bodyPr/>
+                    <a:lstStyle/>
+                    <a:p>
+                      <a:pPr marL="0" indent="0">
+                        <a:buNone/>
+                      </a:pPr>
+                      <a:r>
+                        <a:rPr lang="en-US" sz="1200" dirty="0">
+                          <a:solidFill>
+                            <a:srgbClr val="16202B"/>
+                          </a:solidFill>
+                          <a:latin typeface="Calibri" pitchFamily="34" charset="0"/>
+                          <a:ea typeface="Calibri" pitchFamily="34" charset="-122"/>
+                          <a:cs typeface="Calibri" pitchFamily="34" charset="-120"/>
+                        </a:rPr>
+                        <a:t>A SIM-swap check gating a payment — Orange's banking agent, July 2026</a:t>
+                      </a:r>
+                      <a:endParaRPr lang="en-US" sz="1200" dirty="0">
+                        <a:latin typeface="Calibri" charset="0"/>
+                        <a:ea typeface="Calibri" charset="0"/>
+                        <a:cs typeface="Calibri" charset="0"/>
+                      </a:endParaRPr>
+                    </a:p>
+                  </a:txBody>
+                  <a:tcPr anchor="ctr">
+                    <a:lnL w="6350" cap="flat" cmpd="sng" algn="ctr">
+                      <a:solidFill>
+                        <a:srgbClr val="D8DEE4"/>
+                      </a:solidFill>
+                      <a:prstDash val="solid"/>
+                      <a:round/>
+                      <a:headEnd type="none" w="med" len="med"/>
+                      <a:tailEnd type="none" w="med" len="med"/>
+                    </a:lnL>
+                    <a:lnR w="6350" cap="flat" cmpd="sng" algn="ctr">
+                      <a:solidFill>
+                        <a:srgbClr val="D8DEE4"/>
+                      </a:solidFill>
+                      <a:prstDash val="solid"/>
+                      <a:round/>
+                      <a:headEnd type="none" w="med" len="med"/>
+                      <a:tailEnd type="none" w="med" len="med"/>
+                    </a:lnR>
+                    <a:lnT w="6350" cap="flat" cmpd="sng" algn="ctr">
+                      <a:solidFill>
+                        <a:srgbClr val="D8DEE4"/>
+                      </a:solidFill>
+                      <a:prstDash val="solid"/>
+                      <a:round/>
+                      <a:headEnd type="none" w="med" len="med"/>
+                      <a:tailEnd type="none" w="med" len="med"/>
+                    </a:lnT>
+                    <a:lnB w="6350" cap="flat" cmpd="sng" algn="ctr">
+                      <a:solidFill>
+                        <a:srgbClr val="D8DEE4"/>
+                      </a:solidFill>
+                      <a:prstDash val="solid"/>
+                      <a:round/>
+                      <a:headEnd type="none" w="med" len="med"/>
+                      <a:tailEnd type="none" w="med" len="med"/>
+                    </a:lnB>
+                  </a:tcPr>
+                </a:tc>
+                <a:tc>
+                  <a:txBody>
+                    <a:bodyPr/>
+                    <a:lstStyle/>
+                    <a:p>
+                      <a:pPr marL="0" indent="0">
+                        <a:buNone/>
+                      </a:pPr>
+                      <a:r>
+                        <a:rPr lang="en-US" sz="1200" dirty="0">
+                          <a:solidFill>
+                            <a:srgbClr val="16202B"/>
+                          </a:solidFill>
+                          <a:latin typeface="Calibri" pitchFamily="34" charset="0"/>
+                          <a:ea typeface="Calibri" pitchFamily="34" charset="-122"/>
+                          <a:cs typeface="Calibri" pitchFamily="34" charset="-120"/>
+                        </a:rPr>
+                        <a:t>Gates spectrum, not money: SIM swap, roaming and location verification decide who gets priority bandwidth. No model, no elevation — it fails closed.</a:t>
+                      </a:r>
+                      <a:endParaRPr lang="en-US" sz="1200" dirty="0">
+                        <a:latin typeface="Calibri" charset="0"/>
+                        <a:ea typeface="Calibri" charset="0"/>
+                        <a:cs typeface="Calibri" charset="0"/>
+                      </a:endParaRPr>
+                    </a:p>
+                  </a:txBody>
+                  <a:tcPr anchor="ctr">
+                    <a:lnL w="6350" cap="flat" cmpd="sng" algn="ctr">
+                      <a:solidFill>
+                        <a:srgbClr val="D8DEE4"/>
+                      </a:solidFill>
+                      <a:prstDash val="solid"/>
+                      <a:round/>
+                      <a:headEnd type="none" w="med" len="med"/>
+                      <a:tailEnd type="none" w="med" len="med"/>
+                    </a:lnL>
+                    <a:lnR w="6350" cap="flat" cmpd="sng" algn="ctr">
+                      <a:solidFill>
+                        <a:srgbClr val="D8DEE4"/>
+                      </a:solidFill>
+                      <a:prstDash val="solid"/>
+                      <a:round/>
+                      <a:headEnd type="none" w="med" len="med"/>
+                      <a:tailEnd type="none" w="med" len="med"/>
+                    </a:lnR>
+                    <a:lnT w="6350" cap="flat" cmpd="sng" algn="ctr">
+                      <a:solidFill>
+                        <a:srgbClr val="D8DEE4"/>
+                      </a:solidFill>
+                      <a:prstDash val="solid"/>
+                      <a:round/>
+                      <a:headEnd type="none" w="med" len="med"/>
+                      <a:tailEnd type="none" w="med" len="med"/>
+                    </a:lnT>
+                    <a:lnB w="6350" cap="flat" cmpd="sng" algn="ctr">
+                      <a:solidFill>
+                        <a:srgbClr val="D8DEE4"/>
+                      </a:solidFill>
+                      <a:prstDash val="solid"/>
+                      <a:round/>
+                      <a:headEnd type="none" w="med" len="med"/>
+                      <a:tailEnd type="none" w="med" len="med"/>
+                    </a:lnB>
+                  </a:tcPr>
+                </a:tc>
+                <a:extLst>
+                  <a:ext uri="{0D108BD9-81ED-4DB2-BD59-A6C34878D82A}">
+                    <a16:rowId xmlns:a16="http://schemas.microsoft.com/office/drawing/2014/main" val="10003"/>
+                  </a:ext>
+                </a:extLst>
+              </a:tr>
+            </a:tbl>
+          </a:graphicData>
+        </a:graphic>
+      </p:graphicFrame>
+      <p:sp>
+        <p:nvSpPr>
+          <p:cNvPr id="5" name="Shape 2"/>
+          <p:cNvSpPr/>
+          <p:nvPr/>
+        </p:nvSpPr>
+        <p:spPr>
+          <a:xfrm>
+            <a:off x="8092440" y="1417320"/>
+            <a:ext cx="3566160" cy="4709160"/>
+          </a:xfrm>
+          <a:prstGeom prst="rect">
+            <a:avLst/>
+          </a:prstGeom>
+          <a:solidFill>
+            <a:srgbClr val="0F1B2D"/>
+          </a:solidFill>
+          <a:ln/>
+        </p:spPr>
+      </p:sp>
+      <p:sp>
+        <p:nvSpPr>
+          <p:cNvPr id="6" name="Text 3"/>
+          <p:cNvSpPr/>
+          <p:nvPr/>
+        </p:nvSpPr>
+        <p:spPr>
+          <a:xfrm>
+            <a:off x="8321040" y="1600200"/>
+            <a:ext cx="3108960" cy="365760"/>
+          </a:xfrm>
+          <a:prstGeom prst="rect">
+            <a:avLst/>
+          </a:prstGeom>
+          <a:noFill/>
+          <a:ln/>
+        </p:spPr>
+        <p:txBody>
+          <a:bodyPr wrap="square" lIns="0" tIns="0" rIns="0" bIns="0" rtlCol="0" anchor="ctr"/>
+          <a:lstStyle/>
+          <a:p>
+            <a:pPr marL="0" indent="0">
+              <a:buNone/>
+            </a:pPr>
+            <a:r>
+              <a:rPr lang="en-US" sz="1500" b="1" dirty="0">
+                <a:solidFill>
+                  <a:srgbClr val="FFFFFF"/>
+                </a:solidFill>
+                <a:latin typeface="Cambria" pitchFamily="34" charset="0"/>
+                <a:ea typeface="Cambria" pitchFamily="34" charset="-122"/>
+                <a:cs typeface="Cambria" pitchFamily="34" charset="-120"/>
+              </a:rPr>
+              <a:t>What the control room gains</a:t>
+            </a:r>
+            <a:endParaRPr lang="en-US" sz="1500" dirty="0"/>
+          </a:p>
+        </p:txBody>
+      </p:sp>
+      <p:sp>
+        <p:nvSpPr>
+          <p:cNvPr id="7" name="Text 4"/>
+          <p:cNvSpPr/>
+          <p:nvPr/>
+        </p:nvSpPr>
+        <p:spPr>
+          <a:xfrm>
+            <a:off x="8321040" y="2057400"/>
+            <a:ext cx="3108960" cy="411480"/>
+          </a:xfrm>
+          <a:prstGeom prst="rect">
+            <a:avLst/>
+          </a:prstGeom>
+          <a:noFill/>
+          <a:ln/>
+        </p:spPr>
+        <p:txBody>
+          <a:bodyPr wrap="square" lIns="0" tIns="0" rIns="0" bIns="0" rtlCol="0" anchor="ctr"/>
+          <a:lstStyle/>
+          <a:p>
+            <a:pPr marL="0" indent="0">
+              <a:lnSpc>
+                <a:spcPct val="115000"/>
+              </a:lnSpc>
+              <a:buNone/>
+            </a:pPr>
+            <a:r>
+              <a:rPr lang="en-US" sz="1200" dirty="0">
+                <a:solidFill>
+                  <a:srgbClr val="EDEFE9"/>
+                </a:solidFill>
+                <a:latin typeface="Calibri" pitchFamily="34" charset="0"/>
+                <a:ea typeface="Calibri" pitchFamily="34" charset="-122"/>
+                <a:cs typeface="Calibri" pitchFamily="34" charset="-120"/>
+              </a:rPr>
+              <a:t>• Earlier warning — no new hardware</a:t>
+            </a:r>
+            <a:endParaRPr lang="en-US" sz="1200" dirty="0"/>
+          </a:p>
+        </p:txBody>
+      </p:sp>
+      <p:sp>
+        <p:nvSpPr>
+          <p:cNvPr id="8" name="Text 5"/>
+          <p:cNvSpPr/>
+          <p:nvPr/>
+        </p:nvSpPr>
+        <p:spPr>
+          <a:xfrm>
+            <a:off x="8321040" y="2514600"/>
+            <a:ext cx="3108960" cy="411480"/>
+          </a:xfrm>
+          <a:prstGeom prst="rect">
+            <a:avLst/>
+          </a:prstGeom>
+          <a:noFill/>
+          <a:ln/>
+        </p:spPr>
+        <p:txBody>
+          <a:bodyPr wrap="square" lIns="0" tIns="0" rIns="0" bIns="0" rtlCol="0" anchor="ctr"/>
+          <a:lstStyle/>
+          <a:p>
+            <a:pPr marL="0" indent="0">
+              <a:lnSpc>
+                <a:spcPct val="115000"/>
+              </a:lnSpc>
+              <a:buNone/>
+            </a:pPr>
+            <a:r>
+              <a:rPr lang="en-US" sz="1200" dirty="0">
+                <a:solidFill>
+                  <a:srgbClr val="EDEFE9"/>
+                </a:solidFill>
+                <a:latin typeface="Calibri" pitchFamily="34" charset="0"/>
+                <a:ea typeface="Calibri" pitchFamily="34" charset="-122"/>
+                <a:cs typeface="Calibri" pitchFamily="34" charset="-120"/>
+              </a:rPr>
+              <a:t>• No false comfort from a confident-looking “Low”</a:t>
+            </a:r>
+            <a:endParaRPr lang="en-US" sz="1200" dirty="0"/>
+          </a:p>
+        </p:txBody>
+      </p:sp>
+      <p:sp>
+        <p:nvSpPr>
+          <p:cNvPr id="9" name="Text 6"/>
+          <p:cNvSpPr/>
+          <p:nvPr/>
+        </p:nvSpPr>
+        <p:spPr>
+          <a:xfrm>
+            <a:off x="8321040" y="2971800"/>
+            <a:ext cx="3108960" cy="411480"/>
+          </a:xfrm>
+          <a:prstGeom prst="rect">
+            <a:avLst/>
+          </a:prstGeom>
+          <a:noFill/>
+          <a:ln/>
+        </p:spPr>
+        <p:txBody>
+          <a:bodyPr wrap="square" lIns="0" tIns="0" rIns="0" bIns="0" rtlCol="0" anchor="ctr"/>
+          <a:lstStyle/>
+          <a:p>
+            <a:pPr marL="0" indent="0">
+              <a:lnSpc>
+                <a:spcPct val="115000"/>
+              </a:lnSpc>
+              <a:buNone/>
+            </a:pPr>
+            <a:r>
+              <a:rPr lang="en-US" sz="1200" dirty="0">
+                <a:solidFill>
+                  <a:srgbClr val="EDEFE9"/>
+                </a:solidFill>
+                <a:latin typeface="Calibri" pitchFamily="34" charset="0"/>
+                <a:ea typeface="Calibri" pitchFamily="34" charset="-122"/>
+                <a:cs typeface="Calibri" pitchFamily="34" charset="-120"/>
+              </a:rPr>
+              <a:t>• Priority bandwidth an impersonator cannot obtain</a:t>
+            </a:r>
+            <a:endParaRPr lang="en-US" sz="1200" dirty="0"/>
+          </a:p>
+        </p:txBody>
+      </p:sp>
+      <p:sp>
+        <p:nvSpPr>
+          <p:cNvPr id="10" name="Text 7"/>
+          <p:cNvSpPr/>
+          <p:nvPr/>
+        </p:nvSpPr>
+        <p:spPr>
+          <a:xfrm>
+            <a:off x="8321040" y="3429000"/>
+            <a:ext cx="3108960" cy="411480"/>
+          </a:xfrm>
+          <a:prstGeom prst="rect">
+            <a:avLst/>
+          </a:prstGeom>
+          <a:noFill/>
+          <a:ln/>
+        </p:spPr>
+        <p:txBody>
+          <a:bodyPr wrap="square" lIns="0" tIns="0" rIns="0" bIns="0" rtlCol="0" anchor="ctr"/>
+          <a:lstStyle/>
+          <a:p>
+            <a:pPr marL="0" indent="0">
+              <a:lnSpc>
+                <a:spcPct val="115000"/>
+              </a:lnSpc>
+              <a:buNone/>
+            </a:pPr>
+            <a:r>
+              <a:rPr lang="en-US" sz="1200" dirty="0">
+                <a:solidFill>
+                  <a:srgbClr val="EDEFE9"/>
+                </a:solidFill>
+                <a:latin typeface="Calibri" pitchFamily="34" charset="0"/>
+                <a:ea typeface="Calibri" pitchFamily="34" charset="-122"/>
+                <a:cs typeface="Calibri" pitchFamily="34" charset="-120"/>
+              </a:rPr>
+              <a:t>• Every action explains itself — provenance on every call</a:t>
+            </a:r>
+            <a:endParaRPr lang="en-US" sz="1200" dirty="0"/>
+          </a:p>
+        </p:txBody>
+      </p:sp>
+      <p:sp>
+        <p:nvSpPr>
+          <p:cNvPr id="4" name="Shape 8"/>
+          <p:cNvSpPr/>
+          <p:nvPr/>
+        </p:nvSpPr>
+        <p:spPr>
+          <a:xfrm>
+            <a:off x="8321040" y="3977640"/>
+            <a:ext cx="2880360" cy="0"/>
+          </a:xfrm>
+          <a:prstGeom prst="line">
+            <a:avLst/>
+          </a:prstGeom>
+          <a:noFill/>
+          <a:ln w="6350">
+            <a:solidFill>
+              <a:srgbClr val="9FB0C7"/>
+            </a:solidFill>
+            <a:prstDash val="solid"/>
+          </a:ln>
+        </p:spPr>
+      </p:sp>
+      <p:sp>
+        <p:nvSpPr>
+          <p:cNvPr id="12" name="Text 9"/>
+          <p:cNvSpPr/>
+          <p:nvPr/>
+        </p:nvSpPr>
+        <p:spPr>
+          <a:xfrm>
+            <a:off x="8321040" y="4160520"/>
+            <a:ext cx="3108960" cy="822960"/>
+          </a:xfrm>
+          <a:prstGeom prst="rect">
+            <a:avLst/>
+          </a:prstGeom>
+          <a:noFill/>
+          <a:ln/>
+        </p:spPr>
+        <p:txBody>
+          <a:bodyPr wrap="square" lIns="0" tIns="0" rIns="0" bIns="0" rtlCol="0" anchor="ctr"/>
+          <a:lstStyle/>
+          <a:p>
+            <a:pPr marL="0" indent="0">
+              <a:lnSpc>
+                <a:spcPct val="120000"/>
+              </a:lnSpc>
+              <a:buNone/>
+            </a:pPr>
+            <a:r>
+              <a:rPr lang="en-US" sz="1150" i="1" dirty="0">
+                <a:solidFill>
+                  <a:srgbClr val="C7922E"/>
+                </a:solidFill>
+                <a:latin typeface="Calibri" pitchFamily="34" charset="0"/>
+                <a:ea typeface="Calibri" pitchFamily="34" charset="-122"/>
+                <a:cs typeface="Calibri" pitchFamily="34" charset="-120"/>
+              </a:rPr>
+              <a:t>Sources: Lemaire et al., PLOS ONE 2024 · Orange Flux Vision, Paris 2024 · Nokia × Summit Tech, MWC26 · Orange Developer, Jul 2026 · KFUPM US 12,417,639</a:t>
+            </a:r>
+            <a:endParaRPr lang="en-US" sz="1150" dirty="0"/>
+          </a:p>
+        </p:txBody>
+      </p:sp>
+      <p:sp>
+        <p:nvSpPr>
+          <p:cNvPr id="13" name="Text 10"/>
+          <p:cNvSpPr/>
+          <p:nvPr/>
+        </p:nvSpPr>
+        <p:spPr>
+          <a:xfrm>
+            <a:off x="11368735" y="6400800"/>
+            <a:ext cx="457200" cy="274320"/>
+          </a:xfrm>
+          <a:prstGeom prst="rect">
+            <a:avLst/>
+          </a:prstGeom>
+          <a:noFill/>
+          <a:ln/>
+        </p:spPr>
+        <p:txBody>
+          <a:bodyPr wrap="square" lIns="0" tIns="0" rIns="0" bIns="0" rtlCol="0" anchor="ctr"/>
+          <a:lstStyle/>
+          <a:p>
+            <a:pPr marL="0" indent="0" algn="r">
+              <a:buNone/>
+            </a:pPr>
+            <a:r>
+              <a:rPr lang="en-US" sz="1000" dirty="0">
+                <a:solidFill>
+                  <a:srgbClr val="5B6B7A"/>
+                </a:solidFill>
+                <a:latin typeface="Courier New" pitchFamily="34" charset="0"/>
+                <a:ea typeface="Courier New" pitchFamily="34" charset="-122"/>
+                <a:cs typeface="Courier New" pitchFamily="34" charset="-120"/>
+              </a:rPr>
+              <a:t>12</a:t>
+            </a:r>
+            <a:endParaRPr lang="en-US" sz="1000" dirty="0"/>
           </a:p>
         </p:txBody>
       </p:sp>
@@ -9398,7 +10437,7 @@
                 <a:ea typeface="Cambria" pitchFamily="34" charset="-122"/>
                 <a:cs typeface="Cambria" pitchFamily="34" charset="-120"/>
               </a:rPr>
-              <a:t>5</a:t>
+              <a:t>7</a:t>
             </a:r>
             <a:endParaRPr lang="en-US" sz="2600" dirty="0"/>
           </a:p>
@@ -9440,7 +10479,7 @@
                 <a:ea typeface="Calibri" pitchFamily="34" charset="-122"/>
                 <a:cs typeface="Calibri" pitchFamily="34" charset="-120"/>
               </a:rPr>
-              <a:t>API families exercised live end-to-end</a:t>
+              <a:t>CAMARA APIs exercised live — six inside the cycle</a:t>
             </a:r>
             <a:endParaRPr lang="en-US" sz="1100" dirty="0"/>
           </a:p>
@@ -9479,7 +10518,7 @@
                 <a:ea typeface="Cambria" pitchFamily="34" charset="-122"/>
                 <a:cs typeface="Cambria" pitchFamily="34" charset="-120"/>
               </a:rPr>
-              <a:t>21</a:t>
+              <a:t>53</a:t>
             </a:r>
             <a:endParaRPr lang="en-US" sz="2600" dirty="0"/>
           </a:p>
@@ -9521,7 +10560,7 @@
                 <a:ea typeface="Calibri" pitchFamily="34" charset="-122"/>
                 <a:cs typeface="Calibri" pitchFamily="34" charset="-120"/>
               </a:rPr>
-              <a:t>tests on the confidence-weighting core</a:t>
+              <a:t>automated tests — CI on every push</a:t>
             </a:r>
             <a:endParaRPr lang="en-US" sz="1100" dirty="0"/>
           </a:p>
@@ -13017,7 +14056,7 @@
                 <a:ea typeface="Calibri" pitchFamily="34" charset="-122"/>
                 <a:cs typeface="Calibri" pitchFamily="34" charset="-120"/>
               </a:rPr>
-              <a:t>Idea Phase deliverable is the reasoning, not a polished UI — full operator console and demo video land in the Phase 2 prototype (Sep submission).</a:t>
+              <a:t>Prototype phase: operator console live at sakina.streamlit.app · narrated demo video · 53 tests · CI on every push · replay mode with zero credentials.</a:t>
             </a:r>
             <a:endParaRPr lang="en-US" sz="1200" dirty="0"/>
           </a:p>
@@ -13317,7 +14356,7 @@
                 <a:ea typeface="Cambria" pitchFamily="34" charset="-122"/>
                 <a:cs typeface="Cambria" pitchFamily="34" charset="-120"/>
               </a:rPr>
-              <a:t>5/5</a:t>
+              <a:t>7/7</a:t>
             </a:r>
             <a:endParaRPr lang="en-US" sz="3000" dirty="0"/>
           </a:p>
@@ -13359,7 +14398,7 @@
                 <a:ea typeface="Calibri" pitchFamily="34" charset="-122"/>
                 <a:cs typeface="Calibri" pitchFamily="34" charset="-120"/>
               </a:rPr>
-              <a:t>APIs used by the agent verified live (congestion, location, device_status, sim_swap, QoD)</a:t>
+              <a:t>CAMARA APIs verified live — congestion, location, location verify, device status, SIM swap, QoD, geofencing</a:t>
             </a:r>
             <a:endParaRPr lang="en-US" sz="1150" dirty="0"/>
           </a:p>

</xml_diff>